<commit_message>
Add AI work-screen example slide and update script
Co-Authored-By: Claude Opus 5.5 <noreply@anthropic.com>
Claude-Session: https://claude.ai/code/session_01T64tPu1Ya6m7t5ZGAAJc3x
</commit_message>
<xml_diff>
--- a/KEPCO_보안교육_발표.pptx
+++ b/KEPCO_보안교육_발표.pptx
@@ -12,9 +12,10 @@
     <p:sldId id="260" r:id="rId6"/>
     <p:sldId id="261" r:id="rId7"/>
     <p:sldId id="262" r:id="rId8"/>
+    <p:sldId id="263" r:id="rId9"/>
   </p:sldIdLst>
   <p:notesMasterIdLst>
-    <p:notesMasterId r:id="rId9"/>
+    <p:notesMasterId r:id="rId10"/>
   </p:notesMasterIdLst>
   <p:sldSz cx="12192000" cy="6858000"/>
   <p:notesSz cx="6858000" cy="12192000"/>
@@ -113,31 +114,32 @@
   <p:extLst>
     <p:ext uri="{521415D9-36F7-43E2-AB2F-B90AF26B5E84}">
       <p14:sectionLst xmlns:p14="http://schemas.microsoft.com/office/powerpoint/2010/main">
-        <p14:section name="표지" id="{62deaf04-239b-222a-bb6d-c6af2eaf6cea}">
+        <p14:section name="표지" id="{15bd90ce-132f-26c7-088d-e8d3e1a2cd02}">
           <p14:sldIdLst>
             <p14:sldId id="256"/>
           </p14:sldIdLst>
         </p14:section>
-        <p14:section name="도입 배경" id="{137b70b0-753d-e903-3e8e-70653d634c7b}">
+        <p14:section name="도입 배경" id="{d8e8f86d-dc49-5672-5172-9eceb0a94dc1}">
           <p14:sldIdLst>
             <p14:sldId id="257"/>
           </p14:sldIdLst>
         </p14:section>
-        <p14:section name="핵심 내용" id="{c73f5f50-ee16-2acd-8867-64e969633c24}">
+        <p14:section name="핵심 내용" id="{b35408fe-fe93-dd17-4df5-4ba80cfcba97}">
           <p14:sldIdLst>
             <p14:sldId id="258"/>
             <p14:sldId id="259"/>
           </p14:sldIdLst>
         </p14:section>
-        <p14:section name="제작 과정" id="{3037d83f-7de9-4e43-1494-65c02afbec05}">
+        <p14:section name="제작 과정" id="{6137f6d9-c647-6c1e-14a9-51651f2b1e89}">
           <p14:sldIdLst>
             <p14:sldId id="260"/>
+            <p14:sldId id="261"/>
           </p14:sldIdLst>
         </p14:section>
-        <p14:section name="마무리" id="{ba3cce2c-b993-527a-a0a7-d0824f2a7e06}">
+        <p14:section name="마무리" id="{a8f1252a-9190-5340-0893-1f6078fb2c57}">
           <p14:sldIdLst>
-            <p14:sldId id="261"/>
             <p14:sldId id="262"/>
+            <p14:sldId id="263"/>
           </p14:sldIdLst>
         </p14:section>
       </p14:sectionLst>
@@ -989,8 +991,7 @@
           <a:p>
             <a:r>
               <a:rPr lang="en-US" dirty="0"/>
-              <a:t>짧고 친근한 영상이라 신입사원이 끝까지 보고 오래 기억할 수 있습니다. AI 제작 방식 덕분에 다른 보안 주제로도 빠르게 확장할 수 있습니다.
-[편집 안내] 오른쪽 아래 점선 원에는 파워캣과 에너지보이가 함께 방패를 든 이미지를 넣으세요. 2번 슬라이드의 당황한 에너지보이와 대비되어 '성장' 스토리가 완성됩니다.</a:t>
+              <a:t>실제 작업 화면입니다. ChatGPT로 오프닝과 엔딩을 기획하고 Google Flow용 영상 프롬프트까지 만들었습니다. Gemini와 Google Flow, Veo로 장면 영상과 파워캣 캐릭터 이미지를 만들었고, 발표 기획안은 Claude와 함께 정리했습니다.</a:t>
             </a:r>
             <a:endParaRPr lang="en-US" dirty="0"/>
           </a:p>
@@ -1078,8 +1079,8 @@
           <a:p>
             <a:r>
               <a:rPr lang="en-US" dirty="0"/>
-              <a:t>질문 받겠습니다. 영상은 QR 코드로 언제든 다시 보실 수 있습니다.
-[편집 안내] 흰 상자에 실제 영상 QR 코드를 넣으세요.</a:t>
+              <a:t>짧고 친근한 영상이라 신입사원이 끝까지 보고 오래 기억할 수 있습니다. AI 제작 방식 덕분에 다른 보안 주제로도 빠르게 확장할 수 있습니다.
+[편집 안내] 오른쪽 아래 점선 원에는 파워캣과 에너지보이가 함께 방패를 든 이미지를 넣으세요. 2번 슬라이드의 당황한 에너지보이와 대비되어 '성장' 스토리가 완성됩니다.</a:t>
             </a:r>
             <a:endParaRPr lang="en-US" dirty="0"/>
           </a:p>
@@ -1103,6 +1104,95 @@
             <a:fld id="{F7021451-1387-4CA6-816F-3879F97B5CBC}" type="slidenum">
               <a:rPr lang="en-US"/>
               <a:t>7</a:t>
+            </a:fld>
+            <a:endParaRPr lang="en-US"/>
+          </a:p>
+        </p:txBody>
+      </p:sp>
+    </p:spTree>
+    <p:extLst>
+      <p:ext uri="{BB962C8B-B14F-4D97-AF65-F5344CB8AC3E}">
+        <p14:creationId xmlns:p14="http://schemas.microsoft.com/office/powerpoint/2010/main" val="1024086991"/>
+      </p:ext>
+    </p:extLst>
+  </p:cSld>
+  <p:clrMapOvr>
+    <a:masterClrMapping/>
+  </p:clrMapOvr>
+</p:notes>
+</file>
+
+<file path=ppt/notesSlides/notesSlide8.xml><?xml version="1.0" encoding="utf-8"?>
+<p:notes xmlns:a="http://schemas.openxmlformats.org/drawingml/2006/main" xmlns:r="http://schemas.openxmlformats.org/officeDocument/2006/relationships" xmlns:p="http://schemas.openxmlformats.org/presentationml/2006/main">
+  <p:cSld>
+    <p:spTree>
+      <p:nvGrpSpPr>
+        <p:cNvPr id="1" name=""/>
+        <p:cNvGrpSpPr/>
+        <p:nvPr/>
+      </p:nvGrpSpPr>
+      <p:grpSpPr>
+        <a:xfrm>
+          <a:off x="0" y="0"/>
+          <a:ext cx="0" cy="0"/>
+          <a:chOff x="0" y="0"/>
+          <a:chExt cx="0" cy="0"/>
+        </a:xfrm>
+      </p:grpSpPr>
+      <p:sp>
+        <p:nvSpPr>
+          <p:cNvPr id="2" name="Slide Image Placeholder 1"/>
+          <p:cNvSpPr>
+            <a:spLocks noGrp="1" noRot="1" noChangeAspect="1"/>
+          </p:cNvSpPr>
+          <p:nvPr>
+            <p:ph type="sldImg"/>
+          </p:nvPr>
+        </p:nvSpPr>
+        <p:spPr/>
+      </p:sp>
+      <p:sp>
+        <p:nvSpPr>
+          <p:cNvPr id="3" name="Notes Placeholder 2"/>
+          <p:cNvSpPr>
+            <a:spLocks noGrp="1"/>
+          </p:cNvSpPr>
+          <p:nvPr>
+            <p:ph type="body" idx="1"/>
+          </p:nvPr>
+        </p:nvSpPr>
+        <p:spPr/>
+        <p:txBody>
+          <a:bodyPr/>
+          <a:lstStyle/>
+          <a:p>
+            <a:r>
+              <a:rPr lang="en-US" dirty="0"/>
+              <a:t>질문 받겠습니다. 영상은 QR 코드로 언제든 다시 보실 수 있습니다.
+[편집 안내] 흰 상자에 실제 영상 QR 코드를 넣으세요.</a:t>
+            </a:r>
+            <a:endParaRPr lang="en-US" dirty="0"/>
+          </a:p>
+        </p:txBody>
+      </p:sp>
+      <p:sp>
+        <p:nvSpPr>
+          <p:cNvPr id="4" name="Slide Number Placeholder 3"/>
+          <p:cNvSpPr>
+            <a:spLocks noGrp="1"/>
+          </p:cNvSpPr>
+          <p:nvPr>
+            <p:ph type="sldNum" sz="quarter" idx="10"/>
+          </p:nvPr>
+        </p:nvSpPr>
+        <p:spPr/>
+        <p:txBody>
+          <a:bodyPr/>
+          <a:lstStyle/>
+          <a:p>
+            <a:fld id="{F7021451-1387-4CA6-816F-3879F97B5CBC}" type="slidenum">
+              <a:rPr lang="en-US"/>
+              <a:t>8</a:t>
             </a:fld>
             <a:endParaRPr lang="en-US"/>
           </a:p>
@@ -6969,7 +7059,7 @@
                   <a:schemeClr val="tx2"/>
                 </a:solidFill>
               </a:rPr>
-              <a:t>이렇게 달라집니다</a:t>
+              <a:t>AI와 함께 이렇게 만들었습니다</a:t>
             </a:r>
             <a:endParaRPr lang="en-US" sz="3600" dirty="0"/>
           </a:p>
@@ -6977,49 +7067,99 @@
       </p:sp>
       <p:sp>
         <p:nvSpPr>
-          <p:cNvPr id="3" name="effect-1"/>
+          <p:cNvPr id="3" name="Text 1"/>
+          <p:cNvSpPr txBox="1"/>
+          <p:nvPr/>
+        </p:nvSpPr>
+        <p:spPr>
+          <a:xfrm>
+            <a:off x="548640" y="1188720"/>
+            <a:ext cx="9144000" cy="411480"/>
+          </a:xfrm>
+          <a:prstGeom prst="rect">
+            <a:avLst/>
+          </a:prstGeom>
+          <a:noFill/>
+          <a:ln/>
+        </p:spPr>
+        <p:txBody>
+          <a:bodyPr wrap="square" lIns="0" tIns="0" rIns="0" bIns="0" rtlCol="0" anchor="ctr"/>
+          <a:lstStyle/>
+          <a:p>
+            <a:pPr indent="0" marL="0">
+              <a:buNone/>
+            </a:pPr>
+            <a:r>
+              <a:rPr lang="en-US" sz="1600" dirty="0">
+                <a:solidFill>
+                  <a:schemeClr val="accent4"/>
+                </a:solidFill>
+              </a:rPr>
+              <a:t>기획부터 대본, 영상까지 단계마다 AI를 활용한 실제 작업 화면</a:t>
+            </a:r>
+            <a:endParaRPr lang="en-US" sz="1600" dirty="0"/>
+          </a:p>
+        </p:txBody>
+      </p:sp>
+      <p:sp>
+        <p:nvSpPr>
+          <p:cNvPr id="4" name="shot-ChatGPT"/>
           <p:cNvSpPr/>
           <p:nvPr/>
         </p:nvSpPr>
         <p:spPr>
           <a:xfrm>
-            <a:off x="548640" y="1371600"/>
-            <a:ext cx="3520440" cy="3246120"/>
+            <a:off x="548640" y="1737360"/>
+            <a:ext cx="3931920" cy="4434840"/>
           </a:xfrm>
           <a:prstGeom prst="roundRect">
             <a:avLst>
-              <a:gd name="adj" fmla="val 3380"/>
+              <a:gd name="adj" fmla="val 2791"/>
             </a:avLst>
           </a:prstGeom>
           <a:solidFill>
-            <a:schemeClr val="bg2"/>
+            <a:schemeClr val="bg1"/>
           </a:solidFill>
-          <a:ln/>
-        </p:spPr>
-      </p:sp>
-      <p:sp>
-        <p:nvSpPr>
-          <p:cNvPr id="4" name="Shape 2"/>
+          <a:ln w="12700">
+            <a:solidFill>
+              <a:schemeClr val="accent3"/>
+            </a:solidFill>
+            <a:prstDash val="solid"/>
+          </a:ln>
+          <a:effectLst>
+            <a:outerShdw sx="100000" sy="100000" kx="0" ky="0" algn="bl" rotWithShape="0" blurRad="101600" dist="25400" dir="5400000">
+              <a:srgbClr val="0B2A5B">
+                <a:alpha val="12000"/>
+              </a:srgbClr>
+            </a:outerShdw>
+          </a:effectLst>
+        </p:spPr>
+      </p:sp>
+      <p:sp>
+        <p:nvSpPr>
+          <p:cNvPr id="5" name="Shape 3"/>
           <p:cNvSpPr/>
           <p:nvPr/>
         </p:nvSpPr>
         <p:spPr>
           <a:xfrm>
-            <a:off x="914400" y="1691640"/>
-            <a:ext cx="731520" cy="731520"/>
-          </a:xfrm>
-          <a:prstGeom prst="ellipse">
-            <a:avLst/>
+            <a:off x="685800" y="1874520"/>
+            <a:ext cx="3657600" cy="3108960"/>
+          </a:xfrm>
+          <a:prstGeom prst="roundRect">
+            <a:avLst>
+              <a:gd name="adj" fmla="val 1765"/>
+            </a:avLst>
           </a:prstGeom>
           <a:solidFill>
-            <a:schemeClr val="accent2"/>
+            <a:schemeClr val="tx2"/>
           </a:solidFill>
           <a:ln/>
         </p:spPr>
       </p:sp>
       <p:pic>
         <p:nvPicPr>
-          <p:cNvPr id="5" name="Image 0" descr="preencoded.png">    </p:cNvPr>
+          <p:cNvPr id="6" name="img-ChatGPT" descr="ChatGPT 작업 화면">    </p:cNvPr>
           <p:cNvPicPr>
             <a:picLocks noChangeAspect="1"/>
           </p:cNvPicPr>
@@ -7033,8 +7173,8 @@
         </p:blipFill>
         <p:spPr>
           <a:xfrm>
-            <a:off x="1089965" y="1867205"/>
-            <a:ext cx="380390" cy="380390"/>
+            <a:off x="740664" y="1989451"/>
+            <a:ext cx="3547872" cy="2879098"/>
           </a:xfrm>
           <a:prstGeom prst="rect">
             <a:avLst/>
@@ -7043,147 +7183,19 @@
       </p:pic>
       <p:sp>
         <p:nvSpPr>
-          <p:cNvPr id="6" name="Text 3"/>
-          <p:cNvSpPr txBox="1"/>
-          <p:nvPr/>
-        </p:nvSpPr>
-        <p:spPr>
-          <a:xfrm>
-            <a:off x="914400" y="2560320"/>
-            <a:ext cx="2834640" cy="777240"/>
-          </a:xfrm>
-          <a:prstGeom prst="rect">
-            <a:avLst/>
-          </a:prstGeom>
-          <a:noFill/>
-          <a:ln/>
-        </p:spPr>
-        <p:txBody>
-          <a:bodyPr wrap="square" lIns="0" tIns="0" rIns="0" bIns="0" rtlCol="0" anchor="ctr"/>
-          <a:lstStyle/>
-          <a:p>
-            <a:pPr indent="0" marL="0">
-              <a:buNone/>
-            </a:pPr>
-            <a:r>
-              <a:rPr lang="en-US" sz="4000" b="1" dirty="0">
-                <a:solidFill>
-                  <a:schemeClr val="accent1"/>
-                </a:solidFill>
-              </a:rPr>
-              <a:t>3분</a:t>
-            </a:r>
-            <a:endParaRPr lang="en-US" sz="4000" dirty="0"/>
-          </a:p>
-        </p:txBody>
-      </p:sp>
-      <p:sp>
-        <p:nvSpPr>
-          <p:cNvPr id="7" name="Text 4"/>
-          <p:cNvSpPr txBox="1"/>
-          <p:nvPr/>
-        </p:nvSpPr>
-        <p:spPr>
-          <a:xfrm>
-            <a:off x="914400" y="3337560"/>
-            <a:ext cx="2834640" cy="411480"/>
-          </a:xfrm>
-          <a:prstGeom prst="rect">
-            <a:avLst/>
-          </a:prstGeom>
-          <a:noFill/>
-          <a:ln/>
-        </p:spPr>
-        <p:txBody>
-          <a:bodyPr wrap="square" lIns="0" tIns="0" rIns="0" bIns="0" rtlCol="0" anchor="ctr"/>
-          <a:lstStyle/>
-          <a:p>
-            <a:pPr indent="0" marL="0">
-              <a:buNone/>
-            </a:pPr>
-            <a:r>
-              <a:rPr lang="en-US" sz="1800" b="1" dirty="0">
-                <a:solidFill>
-                  <a:schemeClr val="tx2"/>
-                </a:solidFill>
-              </a:rPr>
-              <a:t>끝까지 보는 교육</a:t>
-            </a:r>
-            <a:endParaRPr lang="en-US" sz="1800" dirty="0"/>
-          </a:p>
-        </p:txBody>
-      </p:sp>
-      <p:sp>
-        <p:nvSpPr>
-          <p:cNvPr id="8" name="Text 5"/>
-          <p:cNvSpPr txBox="1"/>
-          <p:nvPr/>
-        </p:nvSpPr>
-        <p:spPr>
-          <a:xfrm>
-            <a:off x="914400" y="3794760"/>
-            <a:ext cx="2834640" cy="640080"/>
-          </a:xfrm>
-          <a:prstGeom prst="rect">
-            <a:avLst/>
-          </a:prstGeom>
-          <a:noFill/>
-          <a:ln/>
-        </p:spPr>
-        <p:txBody>
-          <a:bodyPr wrap="square" lIns="0" tIns="0" rIns="0" bIns="0" rtlCol="0" anchor="t"/>
-          <a:lstStyle/>
-          <a:p>
-            <a:pPr indent="0" marL="0">
-              <a:buNone/>
-            </a:pPr>
-            <a:r>
-              <a:rPr lang="en-US" sz="1400" dirty="0">
-                <a:solidFill>
-                  <a:schemeClr val="accent4"/>
-                </a:solidFill>
-              </a:rPr>
-              <a:t>짧은 분량으로 이수 부담은 낮추고 몰입도는 높임</a:t>
-            </a:r>
-            <a:endParaRPr lang="en-US" sz="1400" dirty="0"/>
-          </a:p>
-        </p:txBody>
-      </p:sp>
-      <p:sp>
-        <p:nvSpPr>
-          <p:cNvPr id="9" name="effect-2"/>
+          <p:cNvPr id="7" name="Shape 4"/>
           <p:cNvSpPr/>
           <p:nvPr/>
         </p:nvSpPr>
         <p:spPr>
           <a:xfrm>
-            <a:off x="4352544" y="1371600"/>
-            <a:ext cx="3520440" cy="3246120"/>
+            <a:off x="2066544" y="5093208"/>
+            <a:ext cx="896112" cy="329184"/>
           </a:xfrm>
           <a:prstGeom prst="roundRect">
             <a:avLst>
-              <a:gd name="adj" fmla="val 3380"/>
+              <a:gd name="adj" fmla="val 50000"/>
             </a:avLst>
-          </a:prstGeom>
-          <a:solidFill>
-            <a:schemeClr val="bg2"/>
-          </a:solidFill>
-          <a:ln/>
-        </p:spPr>
-      </p:sp>
-      <p:sp>
-        <p:nvSpPr>
-          <p:cNvPr id="10" name="Shape 7"/>
-          <p:cNvSpPr/>
-          <p:nvPr/>
-        </p:nvSpPr>
-        <p:spPr>
-          <a:xfrm>
-            <a:off x="4718304" y="1691640"/>
-            <a:ext cx="731520" cy="731520"/>
-          </a:xfrm>
-          <a:prstGeom prst="ellipse">
-            <a:avLst/>
           </a:prstGeom>
           <a:solidFill>
             <a:schemeClr val="accent2"/>
@@ -7191,9 +7203,137 @@
           <a:ln/>
         </p:spPr>
       </p:sp>
+      <p:sp>
+        <p:nvSpPr>
+          <p:cNvPr id="8" name="Text 5"/>
+          <p:cNvSpPr txBox="1"/>
+          <p:nvPr/>
+        </p:nvSpPr>
+        <p:spPr>
+          <a:xfrm>
+            <a:off x="2066544" y="5093208"/>
+            <a:ext cx="896112" cy="329184"/>
+          </a:xfrm>
+          <a:prstGeom prst="rect">
+            <a:avLst/>
+          </a:prstGeom>
+          <a:noFill/>
+          <a:ln/>
+        </p:spPr>
+        <p:txBody>
+          <a:bodyPr wrap="square" lIns="0" tIns="0" rIns="0" bIns="0" rtlCol="0" anchor="ctr"/>
+          <a:lstStyle/>
+          <a:p>
+            <a:pPr algn="ctr" indent="0" marL="0">
+              <a:buNone/>
+            </a:pPr>
+            <a:r>
+              <a:rPr lang="en-US" sz="1400" b="1" dirty="0">
+                <a:solidFill>
+                  <a:schemeClr val="tx2"/>
+                </a:solidFill>
+              </a:rPr>
+              <a:t>ChatGPT</a:t>
+            </a:r>
+            <a:endParaRPr lang="en-US" sz="1400" dirty="0"/>
+          </a:p>
+        </p:txBody>
+      </p:sp>
+      <p:sp>
+        <p:nvSpPr>
+          <p:cNvPr id="9" name="Text 6"/>
+          <p:cNvSpPr txBox="1"/>
+          <p:nvPr/>
+        </p:nvSpPr>
+        <p:spPr>
+          <a:xfrm>
+            <a:off x="685800" y="5477256"/>
+            <a:ext cx="3657600" cy="548640"/>
+          </a:xfrm>
+          <a:prstGeom prst="rect">
+            <a:avLst/>
+          </a:prstGeom>
+          <a:noFill/>
+          <a:ln/>
+        </p:spPr>
+        <p:txBody>
+          <a:bodyPr wrap="square" lIns="0" tIns="0" rIns="0" bIns="0" rtlCol="0" anchor="ctr"/>
+          <a:lstStyle/>
+          <a:p>
+            <a:pPr algn="ctr" indent="0" marL="0">
+              <a:buNone/>
+            </a:pPr>
+            <a:r>
+              <a:rPr lang="en-US" sz="1300" dirty="0">
+                <a:solidFill>
+                  <a:schemeClr val="tx2"/>
+                </a:solidFill>
+              </a:rPr>
+              <a:t>오프닝·엔딩 기획부터 Google Flow 영상 프롬프트 작성까지</a:t>
+            </a:r>
+            <a:endParaRPr lang="en-US" sz="1300" dirty="0"/>
+          </a:p>
+        </p:txBody>
+      </p:sp>
+      <p:sp>
+        <p:nvSpPr>
+          <p:cNvPr id="10" name="shot-Claude"/>
+          <p:cNvSpPr/>
+          <p:nvPr/>
+        </p:nvSpPr>
+        <p:spPr>
+          <a:xfrm>
+            <a:off x="4709160" y="1737360"/>
+            <a:ext cx="3351276" cy="2103120"/>
+          </a:xfrm>
+          <a:prstGeom prst="roundRect">
+            <a:avLst>
+              <a:gd name="adj" fmla="val 5217"/>
+            </a:avLst>
+          </a:prstGeom>
+          <a:solidFill>
+            <a:schemeClr val="bg1"/>
+          </a:solidFill>
+          <a:ln w="12700">
+            <a:solidFill>
+              <a:schemeClr val="accent3"/>
+            </a:solidFill>
+            <a:prstDash val="solid"/>
+          </a:ln>
+          <a:effectLst>
+            <a:outerShdw sx="100000" sy="100000" kx="0" ky="0" algn="bl" rotWithShape="0" blurRad="101600" dist="25400" dir="5400000">
+              <a:srgbClr val="0B2A5B">
+                <a:alpha val="12000"/>
+              </a:srgbClr>
+            </a:outerShdw>
+          </a:effectLst>
+        </p:spPr>
+      </p:sp>
+      <p:sp>
+        <p:nvSpPr>
+          <p:cNvPr id="11" name="Shape 8"/>
+          <p:cNvSpPr/>
+          <p:nvPr/>
+        </p:nvSpPr>
+        <p:spPr>
+          <a:xfrm>
+            <a:off x="4846320" y="1874520"/>
+            <a:ext cx="3076956" cy="1371600"/>
+          </a:xfrm>
+          <a:prstGeom prst="roundRect">
+            <a:avLst>
+              <a:gd name="adj" fmla="val 4000"/>
+            </a:avLst>
+          </a:prstGeom>
+          <a:solidFill>
+            <a:schemeClr val="tx2"/>
+          </a:solidFill>
+          <a:ln/>
+        </p:spPr>
+      </p:sp>
       <p:pic>
         <p:nvPicPr>
-          <p:cNvPr id="11" name="Image 1" descr="preencoded.png">    </p:cNvPr>
+          <p:cNvPr id="12" name="img-Claude" descr="Claude 작업 화면">    </p:cNvPr>
           <p:cNvPicPr>
             <a:picLocks noChangeAspect="1"/>
           </p:cNvPicPr>
@@ -7207,8 +7347,8 @@
         </p:blipFill>
         <p:spPr>
           <a:xfrm>
-            <a:off x="4893869" y="1867205"/>
-            <a:ext cx="380390" cy="380390"/>
+            <a:off x="5145731" y="1929384"/>
+            <a:ext cx="2478134" cy="1261872"/>
           </a:xfrm>
           <a:prstGeom prst="rect">
             <a:avLst/>
@@ -7217,147 +7357,19 @@
       </p:pic>
       <p:sp>
         <p:nvSpPr>
-          <p:cNvPr id="12" name="Text 8"/>
-          <p:cNvSpPr txBox="1"/>
-          <p:nvPr/>
-        </p:nvSpPr>
-        <p:spPr>
-          <a:xfrm>
-            <a:off x="4718304" y="2560320"/>
-            <a:ext cx="2834640" cy="777240"/>
-          </a:xfrm>
-          <a:prstGeom prst="rect">
-            <a:avLst/>
-          </a:prstGeom>
-          <a:noFill/>
-          <a:ln/>
-        </p:spPr>
-        <p:txBody>
-          <a:bodyPr wrap="square" lIns="0" tIns="0" rIns="0" bIns="0" rtlCol="0" anchor="ctr"/>
-          <a:lstStyle/>
-          <a:p>
-            <a:pPr indent="0" marL="0">
-              <a:buNone/>
-            </a:pPr>
-            <a:r>
-              <a:rPr lang="en-US" sz="4000" b="1" dirty="0">
-                <a:solidFill>
-                  <a:schemeClr val="accent1"/>
-                </a:solidFill>
-              </a:rPr>
-              <a:t>캐릭터</a:t>
-            </a:r>
-            <a:endParaRPr lang="en-US" sz="4000" dirty="0"/>
-          </a:p>
-        </p:txBody>
-      </p:sp>
-      <p:sp>
-        <p:nvSpPr>
-          <p:cNvPr id="13" name="Text 9"/>
-          <p:cNvSpPr txBox="1"/>
-          <p:nvPr/>
-        </p:nvSpPr>
-        <p:spPr>
-          <a:xfrm>
-            <a:off x="4718304" y="3337560"/>
-            <a:ext cx="2834640" cy="411480"/>
-          </a:xfrm>
-          <a:prstGeom prst="rect">
-            <a:avLst/>
-          </a:prstGeom>
-          <a:noFill/>
-          <a:ln/>
-        </p:spPr>
-        <p:txBody>
-          <a:bodyPr wrap="square" lIns="0" tIns="0" rIns="0" bIns="0" rtlCol="0" anchor="ctr"/>
-          <a:lstStyle/>
-          <a:p>
-            <a:pPr indent="0" marL="0">
-              <a:buNone/>
-            </a:pPr>
-            <a:r>
-              <a:rPr lang="en-US" sz="1800" b="1" dirty="0">
-                <a:solidFill>
-                  <a:schemeClr val="tx2"/>
-                </a:solidFill>
-              </a:rPr>
-              <a:t>오래 기억되는 습관</a:t>
-            </a:r>
-            <a:endParaRPr lang="en-US" sz="1800" dirty="0"/>
-          </a:p>
-        </p:txBody>
-      </p:sp>
-      <p:sp>
-        <p:nvSpPr>
-          <p:cNvPr id="14" name="Text 10"/>
-          <p:cNvSpPr txBox="1"/>
-          <p:nvPr/>
-        </p:nvSpPr>
-        <p:spPr>
-          <a:xfrm>
-            <a:off x="4718304" y="3794760"/>
-            <a:ext cx="2834640" cy="640080"/>
-          </a:xfrm>
-          <a:prstGeom prst="rect">
-            <a:avLst/>
-          </a:prstGeom>
-          <a:noFill/>
-          <a:ln/>
-        </p:spPr>
-        <p:txBody>
-          <a:bodyPr wrap="square" lIns="0" tIns="0" rIns="0" bIns="0" rtlCol="0" anchor="t"/>
-          <a:lstStyle/>
-          <a:p>
-            <a:pPr indent="0" marL="0">
-              <a:buNone/>
-            </a:pPr>
-            <a:r>
-              <a:rPr lang="en-US" sz="1400" dirty="0">
-                <a:solidFill>
-                  <a:schemeClr val="accent4"/>
-                </a:solidFill>
-              </a:rPr>
-              <a:t>에너지보이의 실수에 공감하며 자연스럽게 학습</a:t>
-            </a:r>
-            <a:endParaRPr lang="en-US" sz="1400" dirty="0"/>
-          </a:p>
-        </p:txBody>
-      </p:sp>
-      <p:sp>
-        <p:nvSpPr>
-          <p:cNvPr id="15" name="effect-3"/>
+          <p:cNvPr id="13" name="Shape 9"/>
           <p:cNvSpPr/>
           <p:nvPr/>
         </p:nvSpPr>
         <p:spPr>
           <a:xfrm>
-            <a:off x="8156448" y="1371600"/>
-            <a:ext cx="3520440" cy="3246120"/>
+            <a:off x="4846320" y="3328416"/>
+            <a:ext cx="813816" cy="310896"/>
           </a:xfrm>
           <a:prstGeom prst="roundRect">
             <a:avLst>
-              <a:gd name="adj" fmla="val 3380"/>
+              <a:gd name="adj" fmla="val 50000"/>
             </a:avLst>
-          </a:prstGeom>
-          <a:solidFill>
-            <a:schemeClr val="bg2"/>
-          </a:solidFill>
-          <a:ln/>
-        </p:spPr>
-      </p:sp>
-      <p:sp>
-        <p:nvSpPr>
-          <p:cNvPr id="16" name="Shape 12"/>
-          <p:cNvSpPr/>
-          <p:nvPr/>
-        </p:nvSpPr>
-        <p:spPr>
-          <a:xfrm>
-            <a:off x="8522208" y="1691640"/>
-            <a:ext cx="731520" cy="731520"/>
-          </a:xfrm>
-          <a:prstGeom prst="ellipse">
-            <a:avLst/>
           </a:prstGeom>
           <a:solidFill>
             <a:schemeClr val="accent2"/>
@@ -7365,9 +7377,137 @@
           <a:ln/>
         </p:spPr>
       </p:sp>
+      <p:sp>
+        <p:nvSpPr>
+          <p:cNvPr id="14" name="Text 10"/>
+          <p:cNvSpPr txBox="1"/>
+          <p:nvPr/>
+        </p:nvSpPr>
+        <p:spPr>
+          <a:xfrm>
+            <a:off x="4846320" y="3328416"/>
+            <a:ext cx="813816" cy="310896"/>
+          </a:xfrm>
+          <a:prstGeom prst="rect">
+            <a:avLst/>
+          </a:prstGeom>
+          <a:noFill/>
+          <a:ln/>
+        </p:spPr>
+        <p:txBody>
+          <a:bodyPr wrap="square" lIns="0" tIns="0" rIns="0" bIns="0" rtlCol="0" anchor="ctr"/>
+          <a:lstStyle/>
+          <a:p>
+            <a:pPr algn="ctr" indent="0" marL="0">
+              <a:buNone/>
+            </a:pPr>
+            <a:r>
+              <a:rPr lang="en-US" sz="1300" b="1" dirty="0">
+                <a:solidFill>
+                  <a:schemeClr val="tx2"/>
+                </a:solidFill>
+              </a:rPr>
+              <a:t>Claude</a:t>
+            </a:r>
+            <a:endParaRPr lang="en-US" sz="1300" dirty="0"/>
+          </a:p>
+        </p:txBody>
+      </p:sp>
+      <p:sp>
+        <p:nvSpPr>
+          <p:cNvPr id="15" name="Text 11"/>
+          <p:cNvSpPr txBox="1"/>
+          <p:nvPr/>
+        </p:nvSpPr>
+        <p:spPr>
+          <a:xfrm>
+            <a:off x="5769864" y="3328416"/>
+            <a:ext cx="2153412" cy="310896"/>
+          </a:xfrm>
+          <a:prstGeom prst="rect">
+            <a:avLst/>
+          </a:prstGeom>
+          <a:noFill/>
+          <a:ln/>
+        </p:spPr>
+        <p:txBody>
+          <a:bodyPr wrap="square" lIns="0" tIns="0" rIns="0" bIns="0" rtlCol="0" anchor="ctr"/>
+          <a:lstStyle/>
+          <a:p>
+            <a:pPr indent="0" marL="0">
+              <a:buNone/>
+            </a:pPr>
+            <a:r>
+              <a:rPr lang="en-US" sz="1200" dirty="0">
+                <a:solidFill>
+                  <a:schemeClr val="tx2"/>
+                </a:solidFill>
+              </a:rPr>
+              <a:t>PPT 기획안 요청</a:t>
+            </a:r>
+            <a:endParaRPr lang="en-US" sz="1200" dirty="0"/>
+          </a:p>
+        </p:txBody>
+      </p:sp>
+      <p:sp>
+        <p:nvSpPr>
+          <p:cNvPr id="16" name="shot-Gemini"/>
+          <p:cNvSpPr/>
+          <p:nvPr/>
+        </p:nvSpPr>
+        <p:spPr>
+          <a:xfrm>
+            <a:off x="8289036" y="1737360"/>
+            <a:ext cx="3351276" cy="2103120"/>
+          </a:xfrm>
+          <a:prstGeom prst="roundRect">
+            <a:avLst>
+              <a:gd name="adj" fmla="val 5217"/>
+            </a:avLst>
+          </a:prstGeom>
+          <a:solidFill>
+            <a:schemeClr val="bg1"/>
+          </a:solidFill>
+          <a:ln w="12700">
+            <a:solidFill>
+              <a:schemeClr val="accent3"/>
+            </a:solidFill>
+            <a:prstDash val="solid"/>
+          </a:ln>
+          <a:effectLst>
+            <a:outerShdw sx="100000" sy="100000" kx="0" ky="0" algn="bl" rotWithShape="0" blurRad="101600" dist="25400" dir="5400000">
+              <a:srgbClr val="0B2A5B">
+                <a:alpha val="12000"/>
+              </a:srgbClr>
+            </a:outerShdw>
+          </a:effectLst>
+        </p:spPr>
+      </p:sp>
+      <p:sp>
+        <p:nvSpPr>
+          <p:cNvPr id="17" name="Shape 13"/>
+          <p:cNvSpPr/>
+          <p:nvPr/>
+        </p:nvSpPr>
+        <p:spPr>
+          <a:xfrm>
+            <a:off x="8426196" y="1874520"/>
+            <a:ext cx="3076956" cy="1371600"/>
+          </a:xfrm>
+          <a:prstGeom prst="roundRect">
+            <a:avLst>
+              <a:gd name="adj" fmla="val 4000"/>
+            </a:avLst>
+          </a:prstGeom>
+          <a:solidFill>
+            <a:schemeClr val="tx2"/>
+          </a:solidFill>
+          <a:ln/>
+        </p:spPr>
+      </p:sp>
       <p:pic>
         <p:nvPicPr>
-          <p:cNvPr id="17" name="Image 2" descr="preencoded.png">    </p:cNvPr>
+          <p:cNvPr id="18" name="img-Gemini" descr="Gemini 작업 화면">    </p:cNvPr>
           <p:cNvPicPr>
             <a:picLocks noChangeAspect="1"/>
           </p:cNvPicPr>
@@ -7381,8 +7521,8 @@
         </p:blipFill>
         <p:spPr>
           <a:xfrm>
-            <a:off x="8697773" y="1867205"/>
-            <a:ext cx="380390" cy="380390"/>
+            <a:off x="8853678" y="1929384"/>
+            <a:ext cx="2221992" cy="1261872"/>
           </a:xfrm>
           <a:prstGeom prst="rect">
             <a:avLst/>
@@ -7391,162 +7531,112 @@
       </p:pic>
       <p:sp>
         <p:nvSpPr>
-          <p:cNvPr id="18" name="Text 13"/>
-          <p:cNvSpPr txBox="1"/>
-          <p:nvPr/>
-        </p:nvSpPr>
-        <p:spPr>
-          <a:xfrm>
-            <a:off x="8522208" y="2560320"/>
-            <a:ext cx="2834640" cy="777240"/>
-          </a:xfrm>
-          <a:prstGeom prst="rect">
-            <a:avLst/>
-          </a:prstGeom>
-          <a:noFill/>
-          <a:ln/>
-        </p:spPr>
-        <p:txBody>
-          <a:bodyPr wrap="square" lIns="0" tIns="0" rIns="0" bIns="0" rtlCol="0" anchor="ctr"/>
-          <a:lstStyle/>
-          <a:p>
-            <a:pPr indent="0" marL="0">
-              <a:buNone/>
-            </a:pPr>
-            <a:r>
-              <a:rPr lang="en-US" sz="4000" b="1" dirty="0">
-                <a:solidFill>
-                  <a:schemeClr val="accent1"/>
-                </a:solidFill>
-              </a:rPr>
-              <a:t>AI 제작</a:t>
-            </a:r>
-            <a:endParaRPr lang="en-US" sz="4000" dirty="0"/>
-          </a:p>
-        </p:txBody>
-      </p:sp>
-      <p:sp>
-        <p:nvSpPr>
-          <p:cNvPr id="19" name="Text 14"/>
-          <p:cNvSpPr txBox="1"/>
-          <p:nvPr/>
-        </p:nvSpPr>
-        <p:spPr>
-          <a:xfrm>
-            <a:off x="8522208" y="3337560"/>
-            <a:ext cx="2834640" cy="411480"/>
-          </a:xfrm>
-          <a:prstGeom prst="rect">
-            <a:avLst/>
-          </a:prstGeom>
-          <a:noFill/>
-          <a:ln/>
-        </p:spPr>
-        <p:txBody>
-          <a:bodyPr wrap="square" lIns="0" tIns="0" rIns="0" bIns="0" rtlCol="0" anchor="ctr"/>
-          <a:lstStyle/>
-          <a:p>
-            <a:pPr indent="0" marL="0">
-              <a:buNone/>
-            </a:pPr>
-            <a:r>
-              <a:rPr lang="en-US" sz="1800" b="1" dirty="0">
-                <a:solidFill>
-                  <a:schemeClr val="tx2"/>
-                </a:solidFill>
-              </a:rPr>
-              <a:t>빠른 주제 확장</a:t>
-            </a:r>
-            <a:endParaRPr lang="en-US" sz="1800" dirty="0"/>
-          </a:p>
-        </p:txBody>
-      </p:sp>
-      <p:sp>
-        <p:nvSpPr>
-          <p:cNvPr id="20" name="Text 15"/>
-          <p:cNvSpPr txBox="1"/>
-          <p:nvPr/>
-        </p:nvSpPr>
-        <p:spPr>
-          <a:xfrm>
-            <a:off x="8522208" y="3794760"/>
-            <a:ext cx="2834640" cy="640080"/>
-          </a:xfrm>
-          <a:prstGeom prst="rect">
-            <a:avLst/>
-          </a:prstGeom>
-          <a:noFill/>
-          <a:ln/>
-        </p:spPr>
-        <p:txBody>
-          <a:bodyPr wrap="square" lIns="0" tIns="0" rIns="0" bIns="0" rtlCol="0" anchor="t"/>
-          <a:lstStyle/>
-          <a:p>
-            <a:pPr indent="0" marL="0">
-              <a:buNone/>
-            </a:pPr>
-            <a:r>
-              <a:rPr lang="en-US" sz="1400" dirty="0">
-                <a:solidFill>
-                  <a:schemeClr val="accent4"/>
-                </a:solidFill>
-              </a:rPr>
-              <a:t>적은 비용 · 짧은 기간으로 시리즈 제작 가능</a:t>
-            </a:r>
-            <a:endParaRPr lang="en-US" sz="1400" dirty="0"/>
-          </a:p>
-        </p:txBody>
-      </p:sp>
-      <p:sp>
-        <p:nvSpPr>
-          <p:cNvPr id="21" name="Text 16"/>
-          <p:cNvSpPr txBox="1"/>
-          <p:nvPr/>
-        </p:nvSpPr>
-        <p:spPr>
-          <a:xfrm>
-            <a:off x="548640" y="5029200"/>
-            <a:ext cx="2377440" cy="411480"/>
-          </a:xfrm>
-          <a:prstGeom prst="rect">
-            <a:avLst/>
-          </a:prstGeom>
-          <a:noFill/>
-          <a:ln/>
-        </p:spPr>
-        <p:txBody>
-          <a:bodyPr wrap="square" lIns="0" tIns="0" rIns="0" bIns="0" rtlCol="0" anchor="ctr"/>
-          <a:lstStyle/>
-          <a:p>
-            <a:pPr indent="0" marL="0">
-              <a:buNone/>
-            </a:pPr>
-            <a:r>
-              <a:rPr lang="en-US" sz="1500" b="1" dirty="0">
-                <a:solidFill>
-                  <a:schemeClr val="tx2"/>
-                </a:solidFill>
-              </a:rPr>
-              <a:t>다음 시리즈 아이디어</a:t>
-            </a:r>
-            <a:endParaRPr lang="en-US" sz="1500" dirty="0"/>
-          </a:p>
-        </p:txBody>
-      </p:sp>
-      <p:sp>
-        <p:nvSpPr>
-          <p:cNvPr id="22" name="Shape 17"/>
+          <p:cNvPr id="19" name="Shape 14"/>
           <p:cNvSpPr/>
           <p:nvPr/>
         </p:nvSpPr>
         <p:spPr>
           <a:xfrm>
-            <a:off x="2926080" y="5029200"/>
-            <a:ext cx="1600200" cy="411480"/>
+            <a:off x="8426196" y="3328416"/>
+            <a:ext cx="813816" cy="310896"/>
           </a:xfrm>
           <a:prstGeom prst="roundRect">
             <a:avLst>
-              <a:gd name="adj" fmla="val 48889"/>
+              <a:gd name="adj" fmla="val 50000"/>
+            </a:avLst>
+          </a:prstGeom>
+          <a:solidFill>
+            <a:schemeClr val="accent2"/>
+          </a:solidFill>
+          <a:ln/>
+        </p:spPr>
+      </p:sp>
+      <p:sp>
+        <p:nvSpPr>
+          <p:cNvPr id="20" name="Text 15"/>
+          <p:cNvSpPr txBox="1"/>
+          <p:nvPr/>
+        </p:nvSpPr>
+        <p:spPr>
+          <a:xfrm>
+            <a:off x="8426196" y="3328416"/>
+            <a:ext cx="813816" cy="310896"/>
+          </a:xfrm>
+          <a:prstGeom prst="rect">
+            <a:avLst/>
+          </a:prstGeom>
+          <a:noFill/>
+          <a:ln/>
+        </p:spPr>
+        <p:txBody>
+          <a:bodyPr wrap="square" lIns="0" tIns="0" rIns="0" bIns="0" rtlCol="0" anchor="ctr"/>
+          <a:lstStyle/>
+          <a:p>
+            <a:pPr algn="ctr" indent="0" marL="0">
+              <a:buNone/>
+            </a:pPr>
+            <a:r>
+              <a:rPr lang="en-US" sz="1300" b="1" dirty="0">
+                <a:solidFill>
+                  <a:schemeClr val="tx2"/>
+                </a:solidFill>
+              </a:rPr>
+              <a:t>Gemini</a:t>
+            </a:r>
+            <a:endParaRPr lang="en-US" sz="1300" dirty="0"/>
+          </a:p>
+        </p:txBody>
+      </p:sp>
+      <p:sp>
+        <p:nvSpPr>
+          <p:cNvPr id="21" name="Text 16"/>
+          <p:cNvSpPr txBox="1"/>
+          <p:nvPr/>
+        </p:nvSpPr>
+        <p:spPr>
+          <a:xfrm>
+            <a:off x="9349740" y="3328416"/>
+            <a:ext cx="2153412" cy="310896"/>
+          </a:xfrm>
+          <a:prstGeom prst="rect">
+            <a:avLst/>
+          </a:prstGeom>
+          <a:noFill/>
+          <a:ln/>
+        </p:spPr>
+        <p:txBody>
+          <a:bodyPr wrap="square" lIns="0" tIns="0" rIns="0" bIns="0" rtlCol="0" anchor="ctr"/>
+          <a:lstStyle/>
+          <a:p>
+            <a:pPr indent="0" marL="0">
+              <a:buNone/>
+            </a:pPr>
+            <a:r>
+              <a:rPr lang="en-US" sz="1200" dirty="0">
+                <a:solidFill>
+                  <a:schemeClr val="tx2"/>
+                </a:solidFill>
+              </a:rPr>
+              <a:t>보안 서류 방치 장면 영상</a:t>
+            </a:r>
+            <a:endParaRPr lang="en-US" sz="1200" dirty="0"/>
+          </a:p>
+        </p:txBody>
+      </p:sp>
+      <p:sp>
+        <p:nvSpPr>
+          <p:cNvPr id="22" name="shot-Google Flow · Veo"/>
+          <p:cNvSpPr/>
+          <p:nvPr/>
+        </p:nvSpPr>
+        <p:spPr>
+          <a:xfrm>
+            <a:off x="4709160" y="4069080"/>
+            <a:ext cx="3351276" cy="2103120"/>
+          </a:xfrm>
+          <a:prstGeom prst="roundRect">
+            <a:avLst>
+              <a:gd name="adj" fmla="val 5217"/>
             </a:avLst>
           </a:prstGeom>
           <a:solidFill>
@@ -7554,62 +7644,173 @@
           </a:solidFill>
           <a:ln w="12700">
             <a:solidFill>
-              <a:schemeClr val="accent1"/>
+              <a:schemeClr val="accent3"/>
             </a:solidFill>
             <a:prstDash val="solid"/>
           </a:ln>
-        </p:spPr>
-      </p:sp>
-      <p:sp>
-        <p:nvSpPr>
-          <p:cNvPr id="23" name="Text 18"/>
-          <p:cNvSpPr txBox="1"/>
-          <p:nvPr/>
-        </p:nvSpPr>
-        <p:spPr>
-          <a:xfrm>
-            <a:off x="2926080" y="5029200"/>
-            <a:ext cx="1600200" cy="411480"/>
-          </a:xfrm>
-          <a:prstGeom prst="rect">
-            <a:avLst/>
-          </a:prstGeom>
-          <a:noFill/>
-          <a:ln/>
-        </p:spPr>
-        <p:txBody>
-          <a:bodyPr wrap="square" lIns="0" tIns="0" rIns="0" bIns="0" rtlCol="0" anchor="ctr"/>
-          <a:lstStyle/>
-          <a:p>
-            <a:pPr algn="ctr" indent="0" marL="0">
-              <a:buNone/>
-            </a:pPr>
-            <a:r>
-              <a:rPr lang="en-US" sz="1300" dirty="0">
-                <a:solidFill>
-                  <a:schemeClr val="accent1"/>
-                </a:solidFill>
-              </a:rPr>
-              <a:t>#USB 사용편</a:t>
-            </a:r>
-            <a:endParaRPr lang="en-US" sz="1300" dirty="0"/>
-          </a:p>
-        </p:txBody>
-      </p:sp>
-      <p:sp>
-        <p:nvSpPr>
-          <p:cNvPr id="24" name="Shape 19"/>
+          <a:effectLst>
+            <a:outerShdw sx="100000" sy="100000" kx="0" ky="0" algn="bl" rotWithShape="0" blurRad="101600" dist="25400" dir="5400000">
+              <a:srgbClr val="0B2A5B">
+                <a:alpha val="12000"/>
+              </a:srgbClr>
+            </a:outerShdw>
+          </a:effectLst>
+        </p:spPr>
+      </p:sp>
+      <p:sp>
+        <p:nvSpPr>
+          <p:cNvPr id="23" name="Shape 18"/>
           <p:cNvSpPr/>
           <p:nvPr/>
         </p:nvSpPr>
         <p:spPr>
           <a:xfrm>
-            <a:off x="4709160" y="5029200"/>
-            <a:ext cx="1600200" cy="411480"/>
+            <a:off x="4846320" y="4206240"/>
+            <a:ext cx="3076956" cy="1371600"/>
           </a:xfrm>
           <a:prstGeom prst="roundRect">
             <a:avLst>
-              <a:gd name="adj" fmla="val 48889"/>
+              <a:gd name="adj" fmla="val 4000"/>
+            </a:avLst>
+          </a:prstGeom>
+          <a:solidFill>
+            <a:schemeClr val="tx2"/>
+          </a:solidFill>
+          <a:ln/>
+        </p:spPr>
+      </p:sp>
+      <p:pic>
+        <p:nvPicPr>
+          <p:cNvPr id="24" name="img-Google Flow · Veo" descr="Google Flow · Veo 작업 화면">    </p:cNvPr>
+          <p:cNvPicPr>
+            <a:picLocks noChangeAspect="1"/>
+          </p:cNvPicPr>
+          <p:nvPr/>
+        </p:nvPicPr>
+        <p:blipFill>
+          <a:blip r:embed="rId4"/>
+          <a:stretch>
+            <a:fillRect/>
+          </a:stretch>
+        </p:blipFill>
+        <p:spPr>
+          <a:xfrm>
+            <a:off x="5266653" y="4261104"/>
+            <a:ext cx="2236291" cy="1261872"/>
+          </a:xfrm>
+          <a:prstGeom prst="rect">
+            <a:avLst/>
+          </a:prstGeom>
+        </p:spPr>
+      </p:pic>
+      <p:sp>
+        <p:nvSpPr>
+          <p:cNvPr id="25" name="Shape 19"/>
+          <p:cNvSpPr/>
+          <p:nvPr/>
+        </p:nvSpPr>
+        <p:spPr>
+          <a:xfrm>
+            <a:off x="4846320" y="5660136"/>
+            <a:ext cx="1719072" cy="310896"/>
+          </a:xfrm>
+          <a:prstGeom prst="roundRect">
+            <a:avLst>
+              <a:gd name="adj" fmla="val 50000"/>
+            </a:avLst>
+          </a:prstGeom>
+          <a:solidFill>
+            <a:schemeClr val="accent2"/>
+          </a:solidFill>
+          <a:ln/>
+        </p:spPr>
+      </p:sp>
+      <p:sp>
+        <p:nvSpPr>
+          <p:cNvPr id="26" name="Text 20"/>
+          <p:cNvSpPr txBox="1"/>
+          <p:nvPr/>
+        </p:nvSpPr>
+        <p:spPr>
+          <a:xfrm>
+            <a:off x="4846320" y="5660136"/>
+            <a:ext cx="1719072" cy="310896"/>
+          </a:xfrm>
+          <a:prstGeom prst="rect">
+            <a:avLst/>
+          </a:prstGeom>
+          <a:noFill/>
+          <a:ln/>
+        </p:spPr>
+        <p:txBody>
+          <a:bodyPr wrap="square" lIns="0" tIns="0" rIns="0" bIns="0" rtlCol="0" anchor="ctr"/>
+          <a:lstStyle/>
+          <a:p>
+            <a:pPr algn="ctr" indent="0" marL="0">
+              <a:buNone/>
+            </a:pPr>
+            <a:r>
+              <a:rPr lang="en-US" sz="1300" b="1" dirty="0">
+                <a:solidFill>
+                  <a:schemeClr val="tx2"/>
+                </a:solidFill>
+              </a:rPr>
+              <a:t>Google Flow · Veo</a:t>
+            </a:r>
+            <a:endParaRPr lang="en-US" sz="1300" dirty="0"/>
+          </a:p>
+        </p:txBody>
+      </p:sp>
+      <p:sp>
+        <p:nvSpPr>
+          <p:cNvPr id="27" name="Text 21"/>
+          <p:cNvSpPr txBox="1"/>
+          <p:nvPr/>
+        </p:nvSpPr>
+        <p:spPr>
+          <a:xfrm>
+            <a:off x="6675120" y="5660136"/>
+            <a:ext cx="1248156" cy="310896"/>
+          </a:xfrm>
+          <a:prstGeom prst="rect">
+            <a:avLst/>
+          </a:prstGeom>
+          <a:noFill/>
+          <a:ln/>
+        </p:spPr>
+        <p:txBody>
+          <a:bodyPr wrap="square" lIns="0" tIns="0" rIns="0" bIns="0" rtlCol="0" anchor="ctr"/>
+          <a:lstStyle/>
+          <a:p>
+            <a:pPr indent="0" marL="0">
+              <a:buNone/>
+            </a:pPr>
+            <a:r>
+              <a:rPr lang="en-US" sz="1200" dirty="0">
+                <a:solidFill>
+                  <a:schemeClr val="tx2"/>
+                </a:solidFill>
+              </a:rPr>
+              <a:t>피싱 메일 영상</a:t>
+            </a:r>
+            <a:endParaRPr lang="en-US" sz="1200" dirty="0"/>
+          </a:p>
+        </p:txBody>
+      </p:sp>
+      <p:sp>
+        <p:nvSpPr>
+          <p:cNvPr id="28" name="shot-Google Flow"/>
+          <p:cNvSpPr/>
+          <p:nvPr/>
+        </p:nvSpPr>
+        <p:spPr>
+          <a:xfrm>
+            <a:off x="8289036" y="4069080"/>
+            <a:ext cx="3351276" cy="2103120"/>
+          </a:xfrm>
+          <a:prstGeom prst="roundRect">
+            <a:avLst>
+              <a:gd name="adj" fmla="val 5217"/>
             </a:avLst>
           </a:prstGeom>
           <a:solidFill>
@@ -7617,85 +7818,97 @@
           </a:solidFill>
           <a:ln w="12700">
             <a:solidFill>
-              <a:schemeClr val="accent1"/>
+              <a:schemeClr val="accent3"/>
             </a:solidFill>
             <a:prstDash val="solid"/>
           </a:ln>
-        </p:spPr>
-      </p:sp>
-      <p:sp>
-        <p:nvSpPr>
-          <p:cNvPr id="25" name="Text 20"/>
-          <p:cNvSpPr txBox="1"/>
-          <p:nvPr/>
-        </p:nvSpPr>
-        <p:spPr>
-          <a:xfrm>
-            <a:off x="4709160" y="5029200"/>
-            <a:ext cx="1600200" cy="411480"/>
-          </a:xfrm>
-          <a:prstGeom prst="rect">
-            <a:avLst/>
-          </a:prstGeom>
-          <a:noFill/>
-          <a:ln/>
-        </p:spPr>
-        <p:txBody>
-          <a:bodyPr wrap="square" lIns="0" tIns="0" rIns="0" bIns="0" rtlCol="0" anchor="ctr"/>
-          <a:lstStyle/>
-          <a:p>
-            <a:pPr algn="ctr" indent="0" marL="0">
-              <a:buNone/>
-            </a:pPr>
-            <a:r>
-              <a:rPr lang="en-US" sz="1300" dirty="0">
-                <a:solidFill>
-                  <a:schemeClr val="accent1"/>
-                </a:solidFill>
-              </a:rPr>
-              <a:t>#재택근무편</a:t>
-            </a:r>
-            <a:endParaRPr lang="en-US" sz="1300" dirty="0"/>
-          </a:p>
-        </p:txBody>
-      </p:sp>
-      <p:sp>
-        <p:nvSpPr>
-          <p:cNvPr id="26" name="Shape 21"/>
+          <a:effectLst>
+            <a:outerShdw sx="100000" sy="100000" kx="0" ky="0" algn="bl" rotWithShape="0" blurRad="101600" dist="25400" dir="5400000">
+              <a:srgbClr val="0B2A5B">
+                <a:alpha val="12000"/>
+              </a:srgbClr>
+            </a:outerShdw>
+          </a:effectLst>
+        </p:spPr>
+      </p:sp>
+      <p:sp>
+        <p:nvSpPr>
+          <p:cNvPr id="29" name="Shape 23"/>
           <p:cNvSpPr/>
           <p:nvPr/>
         </p:nvSpPr>
         <p:spPr>
           <a:xfrm>
-            <a:off x="6492240" y="5029200"/>
-            <a:ext cx="1600200" cy="411480"/>
+            <a:off x="8426196" y="4206240"/>
+            <a:ext cx="3076956" cy="1371600"/>
           </a:xfrm>
           <a:prstGeom prst="roundRect">
             <a:avLst>
-              <a:gd name="adj" fmla="val 48889"/>
+              <a:gd name="adj" fmla="val 4000"/>
             </a:avLst>
           </a:prstGeom>
           <a:solidFill>
-            <a:schemeClr val="bg1"/>
+            <a:schemeClr val="tx2"/>
           </a:solidFill>
-          <a:ln w="12700">
-            <a:solidFill>
-              <a:schemeClr val="accent1"/>
-            </a:solidFill>
-            <a:prstDash val="solid"/>
-          </a:ln>
-        </p:spPr>
-      </p:sp>
-      <p:sp>
-        <p:nvSpPr>
-          <p:cNvPr id="27" name="Text 22"/>
-          <p:cNvSpPr txBox="1"/>
-          <p:nvPr/>
-        </p:nvSpPr>
-        <p:spPr>
-          <a:xfrm>
-            <a:off x="6492240" y="5029200"/>
-            <a:ext cx="1600200" cy="411480"/>
+          <a:ln/>
+        </p:spPr>
+      </p:sp>
+      <p:pic>
+        <p:nvPicPr>
+          <p:cNvPr id="30" name="img-Google Flow" descr="Google Flow 작업 화면">    </p:cNvPr>
+          <p:cNvPicPr>
+            <a:picLocks noChangeAspect="1"/>
+          </p:cNvPicPr>
+          <p:nvPr/>
+        </p:nvPicPr>
+        <p:blipFill>
+          <a:blip r:embed="rId5"/>
+          <a:stretch>
+            <a:fillRect/>
+          </a:stretch>
+        </p:blipFill>
+        <p:spPr>
+          <a:xfrm>
+            <a:off x="9524843" y="4261104"/>
+            <a:ext cx="879661" cy="1261872"/>
+          </a:xfrm>
+          <a:prstGeom prst="rect">
+            <a:avLst/>
+          </a:prstGeom>
+        </p:spPr>
+      </p:pic>
+      <p:sp>
+        <p:nvSpPr>
+          <p:cNvPr id="31" name="Shape 24"/>
+          <p:cNvSpPr/>
+          <p:nvPr/>
+        </p:nvSpPr>
+        <p:spPr>
+          <a:xfrm>
+            <a:off x="8426196" y="5660136"/>
+            <a:ext cx="1225296" cy="310896"/>
+          </a:xfrm>
+          <a:prstGeom prst="roundRect">
+            <a:avLst>
+              <a:gd name="adj" fmla="val 50000"/>
+            </a:avLst>
+          </a:prstGeom>
+          <a:solidFill>
+            <a:schemeClr val="accent2"/>
+          </a:solidFill>
+          <a:ln/>
+        </p:spPr>
+      </p:sp>
+      <p:sp>
+        <p:nvSpPr>
+          <p:cNvPr id="32" name="Text 25"/>
+          <p:cNvSpPr txBox="1"/>
+          <p:nvPr/>
+        </p:nvSpPr>
+        <p:spPr>
+          <a:xfrm>
+            <a:off x="8426196" y="5660136"/>
+            <a:ext cx="1225296" cy="310896"/>
           </a:xfrm>
           <a:prstGeom prst="rect">
             <a:avLst/>
@@ -7711,12 +7924,12 @@
               <a:buNone/>
             </a:pPr>
             <a:r>
-              <a:rPr lang="en-US" sz="1300" dirty="0">
-                <a:solidFill>
-                  <a:schemeClr val="accent1"/>
-                </a:solidFill>
-              </a:rPr>
-              <a:t>#보안점검편</a:t>
+              <a:rPr lang="en-US" sz="1300" b="1" dirty="0">
+                <a:solidFill>
+                  <a:schemeClr val="tx2"/>
+                </a:solidFill>
+              </a:rPr>
+              <a:t>Google Flow</a:t>
             </a:r>
             <a:endParaRPr lang="en-US" sz="1300" dirty="0"/>
           </a:p>
@@ -7724,76 +7937,37 @@
       </p:sp>
       <p:sp>
         <p:nvSpPr>
-          <p:cNvPr id="28" name="mascot-함께"/>
-          <p:cNvSpPr/>
-          <p:nvPr/>
-        </p:nvSpPr>
-        <p:spPr>
-          <a:xfrm>
-            <a:off x="10268712" y="4709160"/>
-            <a:ext cx="1371600" cy="1371600"/>
-          </a:xfrm>
-          <a:prstGeom prst="ellipse">
-            <a:avLst/>
-          </a:prstGeom>
-          <a:solidFill>
-            <a:schemeClr val="accent3"/>
-          </a:solidFill>
-          <a:ln w="15875">
-            <a:solidFill>
-              <a:schemeClr val="accent1"/>
-            </a:solidFill>
-            <a:prstDash val="dash"/>
-          </a:ln>
-        </p:spPr>
-      </p:sp>
-      <p:sp>
-        <p:nvSpPr>
-          <p:cNvPr id="29" name="mascot-함께-label"/>
-          <p:cNvSpPr txBox="1"/>
-          <p:nvPr/>
-        </p:nvSpPr>
-        <p:spPr>
-          <a:xfrm>
-            <a:off x="10268712" y="4709160"/>
-            <a:ext cx="1371600" cy="1371600"/>
-          </a:xfrm>
-          <a:prstGeom prst="rect">
-            <a:avLst/>
-          </a:prstGeom>
-          <a:noFill/>
-          <a:ln/>
-        </p:spPr>
-        <p:txBody>
-          <a:bodyPr wrap="square" lIns="635" tIns="635" rIns="635" bIns="635" rtlCol="0" anchor="ctr"/>
-          <a:lstStyle/>
-          <a:p>
-            <a:pPr algn="ctr" indent="0" marL="0">
-              <a:buNone/>
-            </a:pPr>
-            <a:r>
-              <a:rPr lang="en-US" sz="1300" b="1" dirty="0">
+          <p:cNvPr id="33" name="Text 26"/>
+          <p:cNvSpPr txBox="1"/>
+          <p:nvPr/>
+        </p:nvSpPr>
+        <p:spPr>
+          <a:xfrm>
+            <a:off x="9761220" y="5660136"/>
+            <a:ext cx="1741932" cy="310896"/>
+          </a:xfrm>
+          <a:prstGeom prst="rect">
+            <a:avLst/>
+          </a:prstGeom>
+          <a:noFill/>
+          <a:ln/>
+        </p:spPr>
+        <p:txBody>
+          <a:bodyPr wrap="square" lIns="0" tIns="0" rIns="0" bIns="0" rtlCol="0" anchor="ctr"/>
+          <a:lstStyle/>
+          <a:p>
+            <a:pPr indent="0" marL="0">
+              <a:buNone/>
+            </a:pPr>
+            <a:r>
+              <a:rPr lang="en-US" sz="1200" dirty="0">
                 <a:solidFill>
                   <a:schemeClr val="tx2"/>
                 </a:solidFill>
               </a:rPr>
-              <a:t>함께</a:t>
-            </a:r>
-            <a:endParaRPr lang="en-US" sz="1300" dirty="0"/>
-          </a:p>
-          <a:p>
-            <a:pPr algn="ctr" indent="0" marL="0">
-              <a:buNone/>
-            </a:pPr>
-            <a:r>
-              <a:rPr lang="en-US" sz="1000" dirty="0">
-                <a:solidFill>
-                  <a:schemeClr val="tx2"/>
-                </a:solidFill>
-              </a:rPr>
-              <a:t>방패 들고 미소</a:t>
-            </a:r>
-            <a:endParaRPr lang="en-US" sz="1300" dirty="0"/>
+              <a:t>파워캣 캐릭터 이미지</a:t>
+            </a:r>
+            <a:endParaRPr lang="en-US" sz="1200" dirty="0"/>
           </a:p>
         </p:txBody>
       </p:sp>
@@ -7853,6 +8027,936 @@
 <file path=ppt/slides/slide7.xml><?xml version="1.0" encoding="utf-8"?>
 <p:sld xmlns:a="http://schemas.openxmlformats.org/drawingml/2006/main" xmlns:r="http://schemas.openxmlformats.org/officeDocument/2006/relationships" xmlns:p="http://schemas.openxmlformats.org/presentationml/2006/main">
   <p:cSld name="Slide 7">
+    <p:spTree>
+      <p:nvGrpSpPr>
+        <p:cNvPr id="1" name=""/>
+        <p:cNvGrpSpPr/>
+        <p:nvPr/>
+      </p:nvGrpSpPr>
+      <p:grpSpPr>
+        <a:xfrm>
+          <a:off x="0" y="0"/>
+          <a:ext cx="0" cy="0"/>
+          <a:chOff x="0" y="0"/>
+          <a:chExt cx="0" cy="0"/>
+        </a:xfrm>
+      </p:grpSpPr>
+      <p:sp>
+        <p:nvSpPr>
+          <p:cNvPr id="2" name="Text 3"/>
+          <p:cNvSpPr/>
+          <p:nvPr>
+            <p:ph idx="103" type="title" hasCustomPrompt="1"/>
+          </p:nvPr>
+        </p:nvSpPr>
+        <p:spPr>
+          <a:xfrm>
+            <a:off x="548640" y="365760"/>
+            <a:ext cx="9692640" cy="685800"/>
+          </a:xfrm>
+          <a:prstGeom prst="rect">
+            <a:avLst/>
+          </a:prstGeom>
+          <a:noFill/>
+          <a:ln/>
+        </p:spPr>
+        <p:txBody>
+          <a:bodyPr wrap="square" lIns="0" tIns="0" rIns="0" bIns="0" rtlCol="0" anchor="ctr"/>
+          <a:lstStyle/>
+          <a:p>
+            <a:pPr algn="l" indent="0" marL="0">
+              <a:buNone/>
+            </a:pPr>
+            <a:r>
+              <a:rPr lang="en-US" sz="3600" b="1" dirty="0">
+                <a:solidFill>
+                  <a:schemeClr val="tx2"/>
+                </a:solidFill>
+              </a:rPr>
+              <a:t>이렇게 달라집니다</a:t>
+            </a:r>
+            <a:endParaRPr lang="en-US" sz="3600" dirty="0"/>
+          </a:p>
+        </p:txBody>
+      </p:sp>
+      <p:sp>
+        <p:nvSpPr>
+          <p:cNvPr id="3" name="effect-1"/>
+          <p:cNvSpPr/>
+          <p:nvPr/>
+        </p:nvSpPr>
+        <p:spPr>
+          <a:xfrm>
+            <a:off x="548640" y="1371600"/>
+            <a:ext cx="3520440" cy="3246120"/>
+          </a:xfrm>
+          <a:prstGeom prst="roundRect">
+            <a:avLst>
+              <a:gd name="adj" fmla="val 3380"/>
+            </a:avLst>
+          </a:prstGeom>
+          <a:solidFill>
+            <a:schemeClr val="bg2"/>
+          </a:solidFill>
+          <a:ln/>
+        </p:spPr>
+      </p:sp>
+      <p:sp>
+        <p:nvSpPr>
+          <p:cNvPr id="4" name="Shape 2"/>
+          <p:cNvSpPr/>
+          <p:nvPr/>
+        </p:nvSpPr>
+        <p:spPr>
+          <a:xfrm>
+            <a:off x="914400" y="1691640"/>
+            <a:ext cx="731520" cy="731520"/>
+          </a:xfrm>
+          <a:prstGeom prst="ellipse">
+            <a:avLst/>
+          </a:prstGeom>
+          <a:solidFill>
+            <a:schemeClr val="accent2"/>
+          </a:solidFill>
+          <a:ln/>
+        </p:spPr>
+      </p:sp>
+      <p:pic>
+        <p:nvPicPr>
+          <p:cNvPr id="5" name="Image 0" descr="preencoded.png">    </p:cNvPr>
+          <p:cNvPicPr>
+            <a:picLocks noChangeAspect="1"/>
+          </p:cNvPicPr>
+          <p:nvPr/>
+        </p:nvPicPr>
+        <p:blipFill>
+          <a:blip r:embed="rId1"/>
+          <a:stretch>
+            <a:fillRect/>
+          </a:stretch>
+        </p:blipFill>
+        <p:spPr>
+          <a:xfrm>
+            <a:off x="1089965" y="1867205"/>
+            <a:ext cx="380390" cy="380390"/>
+          </a:xfrm>
+          <a:prstGeom prst="rect">
+            <a:avLst/>
+          </a:prstGeom>
+        </p:spPr>
+      </p:pic>
+      <p:sp>
+        <p:nvSpPr>
+          <p:cNvPr id="6" name="Text 3"/>
+          <p:cNvSpPr txBox="1"/>
+          <p:nvPr/>
+        </p:nvSpPr>
+        <p:spPr>
+          <a:xfrm>
+            <a:off x="914400" y="2560320"/>
+            <a:ext cx="2834640" cy="777240"/>
+          </a:xfrm>
+          <a:prstGeom prst="rect">
+            <a:avLst/>
+          </a:prstGeom>
+          <a:noFill/>
+          <a:ln/>
+        </p:spPr>
+        <p:txBody>
+          <a:bodyPr wrap="square" lIns="0" tIns="0" rIns="0" bIns="0" rtlCol="0" anchor="ctr"/>
+          <a:lstStyle/>
+          <a:p>
+            <a:pPr indent="0" marL="0">
+              <a:buNone/>
+            </a:pPr>
+            <a:r>
+              <a:rPr lang="en-US" sz="4000" b="1" dirty="0">
+                <a:solidFill>
+                  <a:schemeClr val="accent1"/>
+                </a:solidFill>
+              </a:rPr>
+              <a:t>3분</a:t>
+            </a:r>
+            <a:endParaRPr lang="en-US" sz="4000" dirty="0"/>
+          </a:p>
+        </p:txBody>
+      </p:sp>
+      <p:sp>
+        <p:nvSpPr>
+          <p:cNvPr id="7" name="Text 4"/>
+          <p:cNvSpPr txBox="1"/>
+          <p:nvPr/>
+        </p:nvSpPr>
+        <p:spPr>
+          <a:xfrm>
+            <a:off x="914400" y="3337560"/>
+            <a:ext cx="2834640" cy="411480"/>
+          </a:xfrm>
+          <a:prstGeom prst="rect">
+            <a:avLst/>
+          </a:prstGeom>
+          <a:noFill/>
+          <a:ln/>
+        </p:spPr>
+        <p:txBody>
+          <a:bodyPr wrap="square" lIns="0" tIns="0" rIns="0" bIns="0" rtlCol="0" anchor="ctr"/>
+          <a:lstStyle/>
+          <a:p>
+            <a:pPr indent="0" marL="0">
+              <a:buNone/>
+            </a:pPr>
+            <a:r>
+              <a:rPr lang="en-US" sz="1800" b="1" dirty="0">
+                <a:solidFill>
+                  <a:schemeClr val="tx2"/>
+                </a:solidFill>
+              </a:rPr>
+              <a:t>끝까지 보는 교육</a:t>
+            </a:r>
+            <a:endParaRPr lang="en-US" sz="1800" dirty="0"/>
+          </a:p>
+        </p:txBody>
+      </p:sp>
+      <p:sp>
+        <p:nvSpPr>
+          <p:cNvPr id="8" name="Text 5"/>
+          <p:cNvSpPr txBox="1"/>
+          <p:nvPr/>
+        </p:nvSpPr>
+        <p:spPr>
+          <a:xfrm>
+            <a:off x="914400" y="3794760"/>
+            <a:ext cx="2834640" cy="640080"/>
+          </a:xfrm>
+          <a:prstGeom prst="rect">
+            <a:avLst/>
+          </a:prstGeom>
+          <a:noFill/>
+          <a:ln/>
+        </p:spPr>
+        <p:txBody>
+          <a:bodyPr wrap="square" lIns="0" tIns="0" rIns="0" bIns="0" rtlCol="0" anchor="t"/>
+          <a:lstStyle/>
+          <a:p>
+            <a:pPr indent="0" marL="0">
+              <a:buNone/>
+            </a:pPr>
+            <a:r>
+              <a:rPr lang="en-US" sz="1400" dirty="0">
+                <a:solidFill>
+                  <a:schemeClr val="accent4"/>
+                </a:solidFill>
+              </a:rPr>
+              <a:t>짧은 분량으로 이수 부담은 낮추고 몰입도는 높임</a:t>
+            </a:r>
+            <a:endParaRPr lang="en-US" sz="1400" dirty="0"/>
+          </a:p>
+        </p:txBody>
+      </p:sp>
+      <p:sp>
+        <p:nvSpPr>
+          <p:cNvPr id="9" name="effect-2"/>
+          <p:cNvSpPr/>
+          <p:nvPr/>
+        </p:nvSpPr>
+        <p:spPr>
+          <a:xfrm>
+            <a:off x="4352544" y="1371600"/>
+            <a:ext cx="3520440" cy="3246120"/>
+          </a:xfrm>
+          <a:prstGeom prst="roundRect">
+            <a:avLst>
+              <a:gd name="adj" fmla="val 3380"/>
+            </a:avLst>
+          </a:prstGeom>
+          <a:solidFill>
+            <a:schemeClr val="bg2"/>
+          </a:solidFill>
+          <a:ln/>
+        </p:spPr>
+      </p:sp>
+      <p:sp>
+        <p:nvSpPr>
+          <p:cNvPr id="10" name="Shape 7"/>
+          <p:cNvSpPr/>
+          <p:nvPr/>
+        </p:nvSpPr>
+        <p:spPr>
+          <a:xfrm>
+            <a:off x="4718304" y="1691640"/>
+            <a:ext cx="731520" cy="731520"/>
+          </a:xfrm>
+          <a:prstGeom prst="ellipse">
+            <a:avLst/>
+          </a:prstGeom>
+          <a:solidFill>
+            <a:schemeClr val="accent2"/>
+          </a:solidFill>
+          <a:ln/>
+        </p:spPr>
+      </p:sp>
+      <p:pic>
+        <p:nvPicPr>
+          <p:cNvPr id="11" name="Image 1" descr="preencoded.png">    </p:cNvPr>
+          <p:cNvPicPr>
+            <a:picLocks noChangeAspect="1"/>
+          </p:cNvPicPr>
+          <p:nvPr/>
+        </p:nvPicPr>
+        <p:blipFill>
+          <a:blip r:embed="rId2"/>
+          <a:stretch>
+            <a:fillRect/>
+          </a:stretch>
+        </p:blipFill>
+        <p:spPr>
+          <a:xfrm>
+            <a:off x="4893869" y="1867205"/>
+            <a:ext cx="380390" cy="380390"/>
+          </a:xfrm>
+          <a:prstGeom prst="rect">
+            <a:avLst/>
+          </a:prstGeom>
+        </p:spPr>
+      </p:pic>
+      <p:sp>
+        <p:nvSpPr>
+          <p:cNvPr id="12" name="Text 8"/>
+          <p:cNvSpPr txBox="1"/>
+          <p:nvPr/>
+        </p:nvSpPr>
+        <p:spPr>
+          <a:xfrm>
+            <a:off x="4718304" y="2560320"/>
+            <a:ext cx="2834640" cy="777240"/>
+          </a:xfrm>
+          <a:prstGeom prst="rect">
+            <a:avLst/>
+          </a:prstGeom>
+          <a:noFill/>
+          <a:ln/>
+        </p:spPr>
+        <p:txBody>
+          <a:bodyPr wrap="square" lIns="0" tIns="0" rIns="0" bIns="0" rtlCol="0" anchor="ctr"/>
+          <a:lstStyle/>
+          <a:p>
+            <a:pPr indent="0" marL="0">
+              <a:buNone/>
+            </a:pPr>
+            <a:r>
+              <a:rPr lang="en-US" sz="4000" b="1" dirty="0">
+                <a:solidFill>
+                  <a:schemeClr val="accent1"/>
+                </a:solidFill>
+              </a:rPr>
+              <a:t>캐릭터</a:t>
+            </a:r>
+            <a:endParaRPr lang="en-US" sz="4000" dirty="0"/>
+          </a:p>
+        </p:txBody>
+      </p:sp>
+      <p:sp>
+        <p:nvSpPr>
+          <p:cNvPr id="13" name="Text 9"/>
+          <p:cNvSpPr txBox="1"/>
+          <p:nvPr/>
+        </p:nvSpPr>
+        <p:spPr>
+          <a:xfrm>
+            <a:off x="4718304" y="3337560"/>
+            <a:ext cx="2834640" cy="411480"/>
+          </a:xfrm>
+          <a:prstGeom prst="rect">
+            <a:avLst/>
+          </a:prstGeom>
+          <a:noFill/>
+          <a:ln/>
+        </p:spPr>
+        <p:txBody>
+          <a:bodyPr wrap="square" lIns="0" tIns="0" rIns="0" bIns="0" rtlCol="0" anchor="ctr"/>
+          <a:lstStyle/>
+          <a:p>
+            <a:pPr indent="0" marL="0">
+              <a:buNone/>
+            </a:pPr>
+            <a:r>
+              <a:rPr lang="en-US" sz="1800" b="1" dirty="0">
+                <a:solidFill>
+                  <a:schemeClr val="tx2"/>
+                </a:solidFill>
+              </a:rPr>
+              <a:t>오래 기억되는 습관</a:t>
+            </a:r>
+            <a:endParaRPr lang="en-US" sz="1800" dirty="0"/>
+          </a:p>
+        </p:txBody>
+      </p:sp>
+      <p:sp>
+        <p:nvSpPr>
+          <p:cNvPr id="14" name="Text 10"/>
+          <p:cNvSpPr txBox="1"/>
+          <p:nvPr/>
+        </p:nvSpPr>
+        <p:spPr>
+          <a:xfrm>
+            <a:off x="4718304" y="3794760"/>
+            <a:ext cx="2834640" cy="640080"/>
+          </a:xfrm>
+          <a:prstGeom prst="rect">
+            <a:avLst/>
+          </a:prstGeom>
+          <a:noFill/>
+          <a:ln/>
+        </p:spPr>
+        <p:txBody>
+          <a:bodyPr wrap="square" lIns="0" tIns="0" rIns="0" bIns="0" rtlCol="0" anchor="t"/>
+          <a:lstStyle/>
+          <a:p>
+            <a:pPr indent="0" marL="0">
+              <a:buNone/>
+            </a:pPr>
+            <a:r>
+              <a:rPr lang="en-US" sz="1400" dirty="0">
+                <a:solidFill>
+                  <a:schemeClr val="accent4"/>
+                </a:solidFill>
+              </a:rPr>
+              <a:t>에너지보이의 실수에 공감하며 자연스럽게 학습</a:t>
+            </a:r>
+            <a:endParaRPr lang="en-US" sz="1400" dirty="0"/>
+          </a:p>
+        </p:txBody>
+      </p:sp>
+      <p:sp>
+        <p:nvSpPr>
+          <p:cNvPr id="15" name="effect-3"/>
+          <p:cNvSpPr/>
+          <p:nvPr/>
+        </p:nvSpPr>
+        <p:spPr>
+          <a:xfrm>
+            <a:off x="8156448" y="1371600"/>
+            <a:ext cx="3520440" cy="3246120"/>
+          </a:xfrm>
+          <a:prstGeom prst="roundRect">
+            <a:avLst>
+              <a:gd name="adj" fmla="val 3380"/>
+            </a:avLst>
+          </a:prstGeom>
+          <a:solidFill>
+            <a:schemeClr val="bg2"/>
+          </a:solidFill>
+          <a:ln/>
+        </p:spPr>
+      </p:sp>
+      <p:sp>
+        <p:nvSpPr>
+          <p:cNvPr id="16" name="Shape 12"/>
+          <p:cNvSpPr/>
+          <p:nvPr/>
+        </p:nvSpPr>
+        <p:spPr>
+          <a:xfrm>
+            <a:off x="8522208" y="1691640"/>
+            <a:ext cx="731520" cy="731520"/>
+          </a:xfrm>
+          <a:prstGeom prst="ellipse">
+            <a:avLst/>
+          </a:prstGeom>
+          <a:solidFill>
+            <a:schemeClr val="accent2"/>
+          </a:solidFill>
+          <a:ln/>
+        </p:spPr>
+      </p:sp>
+      <p:pic>
+        <p:nvPicPr>
+          <p:cNvPr id="17" name="Image 2" descr="preencoded.png">    </p:cNvPr>
+          <p:cNvPicPr>
+            <a:picLocks noChangeAspect="1"/>
+          </p:cNvPicPr>
+          <p:nvPr/>
+        </p:nvPicPr>
+        <p:blipFill>
+          <a:blip r:embed="rId3"/>
+          <a:stretch>
+            <a:fillRect/>
+          </a:stretch>
+        </p:blipFill>
+        <p:spPr>
+          <a:xfrm>
+            <a:off x="8697773" y="1867205"/>
+            <a:ext cx="380390" cy="380390"/>
+          </a:xfrm>
+          <a:prstGeom prst="rect">
+            <a:avLst/>
+          </a:prstGeom>
+        </p:spPr>
+      </p:pic>
+      <p:sp>
+        <p:nvSpPr>
+          <p:cNvPr id="18" name="Text 13"/>
+          <p:cNvSpPr txBox="1"/>
+          <p:nvPr/>
+        </p:nvSpPr>
+        <p:spPr>
+          <a:xfrm>
+            <a:off x="8522208" y="2560320"/>
+            <a:ext cx="2834640" cy="777240"/>
+          </a:xfrm>
+          <a:prstGeom prst="rect">
+            <a:avLst/>
+          </a:prstGeom>
+          <a:noFill/>
+          <a:ln/>
+        </p:spPr>
+        <p:txBody>
+          <a:bodyPr wrap="square" lIns="0" tIns="0" rIns="0" bIns="0" rtlCol="0" anchor="ctr"/>
+          <a:lstStyle/>
+          <a:p>
+            <a:pPr indent="0" marL="0">
+              <a:buNone/>
+            </a:pPr>
+            <a:r>
+              <a:rPr lang="en-US" sz="4000" b="1" dirty="0">
+                <a:solidFill>
+                  <a:schemeClr val="accent1"/>
+                </a:solidFill>
+              </a:rPr>
+              <a:t>AI 제작</a:t>
+            </a:r>
+            <a:endParaRPr lang="en-US" sz="4000" dirty="0"/>
+          </a:p>
+        </p:txBody>
+      </p:sp>
+      <p:sp>
+        <p:nvSpPr>
+          <p:cNvPr id="19" name="Text 14"/>
+          <p:cNvSpPr txBox="1"/>
+          <p:nvPr/>
+        </p:nvSpPr>
+        <p:spPr>
+          <a:xfrm>
+            <a:off x="8522208" y="3337560"/>
+            <a:ext cx="2834640" cy="411480"/>
+          </a:xfrm>
+          <a:prstGeom prst="rect">
+            <a:avLst/>
+          </a:prstGeom>
+          <a:noFill/>
+          <a:ln/>
+        </p:spPr>
+        <p:txBody>
+          <a:bodyPr wrap="square" lIns="0" tIns="0" rIns="0" bIns="0" rtlCol="0" anchor="ctr"/>
+          <a:lstStyle/>
+          <a:p>
+            <a:pPr indent="0" marL="0">
+              <a:buNone/>
+            </a:pPr>
+            <a:r>
+              <a:rPr lang="en-US" sz="1800" b="1" dirty="0">
+                <a:solidFill>
+                  <a:schemeClr val="tx2"/>
+                </a:solidFill>
+              </a:rPr>
+              <a:t>빠른 주제 확장</a:t>
+            </a:r>
+            <a:endParaRPr lang="en-US" sz="1800" dirty="0"/>
+          </a:p>
+        </p:txBody>
+      </p:sp>
+      <p:sp>
+        <p:nvSpPr>
+          <p:cNvPr id="20" name="Text 15"/>
+          <p:cNvSpPr txBox="1"/>
+          <p:nvPr/>
+        </p:nvSpPr>
+        <p:spPr>
+          <a:xfrm>
+            <a:off x="8522208" y="3794760"/>
+            <a:ext cx="2834640" cy="640080"/>
+          </a:xfrm>
+          <a:prstGeom prst="rect">
+            <a:avLst/>
+          </a:prstGeom>
+          <a:noFill/>
+          <a:ln/>
+        </p:spPr>
+        <p:txBody>
+          <a:bodyPr wrap="square" lIns="0" tIns="0" rIns="0" bIns="0" rtlCol="0" anchor="t"/>
+          <a:lstStyle/>
+          <a:p>
+            <a:pPr indent="0" marL="0">
+              <a:buNone/>
+            </a:pPr>
+            <a:r>
+              <a:rPr lang="en-US" sz="1400" dirty="0">
+                <a:solidFill>
+                  <a:schemeClr val="accent4"/>
+                </a:solidFill>
+              </a:rPr>
+              <a:t>적은 비용 · 짧은 기간으로 시리즈 제작 가능</a:t>
+            </a:r>
+            <a:endParaRPr lang="en-US" sz="1400" dirty="0"/>
+          </a:p>
+        </p:txBody>
+      </p:sp>
+      <p:sp>
+        <p:nvSpPr>
+          <p:cNvPr id="21" name="Text 16"/>
+          <p:cNvSpPr txBox="1"/>
+          <p:nvPr/>
+        </p:nvSpPr>
+        <p:spPr>
+          <a:xfrm>
+            <a:off x="548640" y="5029200"/>
+            <a:ext cx="2377440" cy="411480"/>
+          </a:xfrm>
+          <a:prstGeom prst="rect">
+            <a:avLst/>
+          </a:prstGeom>
+          <a:noFill/>
+          <a:ln/>
+        </p:spPr>
+        <p:txBody>
+          <a:bodyPr wrap="square" lIns="0" tIns="0" rIns="0" bIns="0" rtlCol="0" anchor="ctr"/>
+          <a:lstStyle/>
+          <a:p>
+            <a:pPr indent="0" marL="0">
+              <a:buNone/>
+            </a:pPr>
+            <a:r>
+              <a:rPr lang="en-US" sz="1500" b="1" dirty="0">
+                <a:solidFill>
+                  <a:schemeClr val="tx2"/>
+                </a:solidFill>
+              </a:rPr>
+              <a:t>다음 시리즈 아이디어</a:t>
+            </a:r>
+            <a:endParaRPr lang="en-US" sz="1500" dirty="0"/>
+          </a:p>
+        </p:txBody>
+      </p:sp>
+      <p:sp>
+        <p:nvSpPr>
+          <p:cNvPr id="22" name="Shape 17"/>
+          <p:cNvSpPr/>
+          <p:nvPr/>
+        </p:nvSpPr>
+        <p:spPr>
+          <a:xfrm>
+            <a:off x="2926080" y="5029200"/>
+            <a:ext cx="1600200" cy="411480"/>
+          </a:xfrm>
+          <a:prstGeom prst="roundRect">
+            <a:avLst>
+              <a:gd name="adj" fmla="val 48889"/>
+            </a:avLst>
+          </a:prstGeom>
+          <a:solidFill>
+            <a:schemeClr val="bg1"/>
+          </a:solidFill>
+          <a:ln w="12700">
+            <a:solidFill>
+              <a:schemeClr val="accent1"/>
+            </a:solidFill>
+            <a:prstDash val="solid"/>
+          </a:ln>
+        </p:spPr>
+      </p:sp>
+      <p:sp>
+        <p:nvSpPr>
+          <p:cNvPr id="23" name="Text 18"/>
+          <p:cNvSpPr txBox="1"/>
+          <p:nvPr/>
+        </p:nvSpPr>
+        <p:spPr>
+          <a:xfrm>
+            <a:off x="2926080" y="5029200"/>
+            <a:ext cx="1600200" cy="411480"/>
+          </a:xfrm>
+          <a:prstGeom prst="rect">
+            <a:avLst/>
+          </a:prstGeom>
+          <a:noFill/>
+          <a:ln/>
+        </p:spPr>
+        <p:txBody>
+          <a:bodyPr wrap="square" lIns="0" tIns="0" rIns="0" bIns="0" rtlCol="0" anchor="ctr"/>
+          <a:lstStyle/>
+          <a:p>
+            <a:pPr algn="ctr" indent="0" marL="0">
+              <a:buNone/>
+            </a:pPr>
+            <a:r>
+              <a:rPr lang="en-US" sz="1300" dirty="0">
+                <a:solidFill>
+                  <a:schemeClr val="accent1"/>
+                </a:solidFill>
+              </a:rPr>
+              <a:t>#USB 사용편</a:t>
+            </a:r>
+            <a:endParaRPr lang="en-US" sz="1300" dirty="0"/>
+          </a:p>
+        </p:txBody>
+      </p:sp>
+      <p:sp>
+        <p:nvSpPr>
+          <p:cNvPr id="24" name="Shape 19"/>
+          <p:cNvSpPr/>
+          <p:nvPr/>
+        </p:nvSpPr>
+        <p:spPr>
+          <a:xfrm>
+            <a:off x="4709160" y="5029200"/>
+            <a:ext cx="1600200" cy="411480"/>
+          </a:xfrm>
+          <a:prstGeom prst="roundRect">
+            <a:avLst>
+              <a:gd name="adj" fmla="val 48889"/>
+            </a:avLst>
+          </a:prstGeom>
+          <a:solidFill>
+            <a:schemeClr val="bg1"/>
+          </a:solidFill>
+          <a:ln w="12700">
+            <a:solidFill>
+              <a:schemeClr val="accent1"/>
+            </a:solidFill>
+            <a:prstDash val="solid"/>
+          </a:ln>
+        </p:spPr>
+      </p:sp>
+      <p:sp>
+        <p:nvSpPr>
+          <p:cNvPr id="25" name="Text 20"/>
+          <p:cNvSpPr txBox="1"/>
+          <p:nvPr/>
+        </p:nvSpPr>
+        <p:spPr>
+          <a:xfrm>
+            <a:off x="4709160" y="5029200"/>
+            <a:ext cx="1600200" cy="411480"/>
+          </a:xfrm>
+          <a:prstGeom prst="rect">
+            <a:avLst/>
+          </a:prstGeom>
+          <a:noFill/>
+          <a:ln/>
+        </p:spPr>
+        <p:txBody>
+          <a:bodyPr wrap="square" lIns="0" tIns="0" rIns="0" bIns="0" rtlCol="0" anchor="ctr"/>
+          <a:lstStyle/>
+          <a:p>
+            <a:pPr algn="ctr" indent="0" marL="0">
+              <a:buNone/>
+            </a:pPr>
+            <a:r>
+              <a:rPr lang="en-US" sz="1300" dirty="0">
+                <a:solidFill>
+                  <a:schemeClr val="accent1"/>
+                </a:solidFill>
+              </a:rPr>
+              <a:t>#재택근무편</a:t>
+            </a:r>
+            <a:endParaRPr lang="en-US" sz="1300" dirty="0"/>
+          </a:p>
+        </p:txBody>
+      </p:sp>
+      <p:sp>
+        <p:nvSpPr>
+          <p:cNvPr id="26" name="Shape 21"/>
+          <p:cNvSpPr/>
+          <p:nvPr/>
+        </p:nvSpPr>
+        <p:spPr>
+          <a:xfrm>
+            <a:off x="6492240" y="5029200"/>
+            <a:ext cx="1600200" cy="411480"/>
+          </a:xfrm>
+          <a:prstGeom prst="roundRect">
+            <a:avLst>
+              <a:gd name="adj" fmla="val 48889"/>
+            </a:avLst>
+          </a:prstGeom>
+          <a:solidFill>
+            <a:schemeClr val="bg1"/>
+          </a:solidFill>
+          <a:ln w="12700">
+            <a:solidFill>
+              <a:schemeClr val="accent1"/>
+            </a:solidFill>
+            <a:prstDash val="solid"/>
+          </a:ln>
+        </p:spPr>
+      </p:sp>
+      <p:sp>
+        <p:nvSpPr>
+          <p:cNvPr id="27" name="Text 22"/>
+          <p:cNvSpPr txBox="1"/>
+          <p:nvPr/>
+        </p:nvSpPr>
+        <p:spPr>
+          <a:xfrm>
+            <a:off x="6492240" y="5029200"/>
+            <a:ext cx="1600200" cy="411480"/>
+          </a:xfrm>
+          <a:prstGeom prst="rect">
+            <a:avLst/>
+          </a:prstGeom>
+          <a:noFill/>
+          <a:ln/>
+        </p:spPr>
+        <p:txBody>
+          <a:bodyPr wrap="square" lIns="0" tIns="0" rIns="0" bIns="0" rtlCol="0" anchor="ctr"/>
+          <a:lstStyle/>
+          <a:p>
+            <a:pPr algn="ctr" indent="0" marL="0">
+              <a:buNone/>
+            </a:pPr>
+            <a:r>
+              <a:rPr lang="en-US" sz="1300" dirty="0">
+                <a:solidFill>
+                  <a:schemeClr val="accent1"/>
+                </a:solidFill>
+              </a:rPr>
+              <a:t>#보안점검편</a:t>
+            </a:r>
+            <a:endParaRPr lang="en-US" sz="1300" dirty="0"/>
+          </a:p>
+        </p:txBody>
+      </p:sp>
+      <p:sp>
+        <p:nvSpPr>
+          <p:cNvPr id="28" name="mascot-함께"/>
+          <p:cNvSpPr/>
+          <p:nvPr/>
+        </p:nvSpPr>
+        <p:spPr>
+          <a:xfrm>
+            <a:off x="10268712" y="4709160"/>
+            <a:ext cx="1371600" cy="1371600"/>
+          </a:xfrm>
+          <a:prstGeom prst="ellipse">
+            <a:avLst/>
+          </a:prstGeom>
+          <a:solidFill>
+            <a:schemeClr val="accent3"/>
+          </a:solidFill>
+          <a:ln w="15875">
+            <a:solidFill>
+              <a:schemeClr val="accent1"/>
+            </a:solidFill>
+            <a:prstDash val="dash"/>
+          </a:ln>
+        </p:spPr>
+      </p:sp>
+      <p:sp>
+        <p:nvSpPr>
+          <p:cNvPr id="29" name="mascot-함께-label"/>
+          <p:cNvSpPr txBox="1"/>
+          <p:nvPr/>
+        </p:nvSpPr>
+        <p:spPr>
+          <a:xfrm>
+            <a:off x="10268712" y="4709160"/>
+            <a:ext cx="1371600" cy="1371600"/>
+          </a:xfrm>
+          <a:prstGeom prst="rect">
+            <a:avLst/>
+          </a:prstGeom>
+          <a:noFill/>
+          <a:ln/>
+        </p:spPr>
+        <p:txBody>
+          <a:bodyPr wrap="square" lIns="635" tIns="635" rIns="635" bIns="635" rtlCol="0" anchor="ctr"/>
+          <a:lstStyle/>
+          <a:p>
+            <a:pPr algn="ctr" indent="0" marL="0">
+              <a:buNone/>
+            </a:pPr>
+            <a:r>
+              <a:rPr lang="en-US" sz="1300" b="1" dirty="0">
+                <a:solidFill>
+                  <a:schemeClr val="tx2"/>
+                </a:solidFill>
+              </a:rPr>
+              <a:t>함께</a:t>
+            </a:r>
+            <a:endParaRPr lang="en-US" sz="1300" dirty="0"/>
+          </a:p>
+          <a:p>
+            <a:pPr algn="ctr" indent="0" marL="0">
+              <a:buNone/>
+            </a:pPr>
+            <a:r>
+              <a:rPr lang="en-US" sz="1000" dirty="0">
+                <a:solidFill>
+                  <a:schemeClr val="tx2"/>
+                </a:solidFill>
+              </a:rPr>
+              <a:t>방패 들고 미소</a:t>
+            </a:r>
+            <a:endParaRPr lang="en-US" sz="1300" dirty="0"/>
+          </a:p>
+        </p:txBody>
+      </p:sp>
+      <p:sp>
+        <p:nvSpPr>
+          <p:cNvPr id="25" name="Slide Number Placeholder 0"/>
+          <p:cNvSpPr>
+            <a:spLocks noGrp="1"/>
+          </p:cNvSpPr>
+          <p:nvPr>
+            <p:ph type="sldNum" sz="quarter" idx="4294967295"/>
+          </p:nvPr>
+        </p:nvSpPr>
+        <p:spPr>
+          <a:xfrm>
+            <a:off x="11183112" y="6355080"/>
+            <a:ext cx="457200" cy="274320"/>
+          </a:xfrm>
+          <a:prstGeom prst="rect">
+            <a:avLst/>
+          </a:prstGeom>
+          <a:extLst>
+            <a:ext uri="{C572A759-6A51-4108-AA02-DFA0A04FC94B}">
+              <ma14:wrappingTextBoxFlag xmlns:ma14="http://schemas.microsoft.com/office/mac/drawingml/2011/main" val="0"/>
+            </a:ext>
+          </a:extLst>
+        </p:spPr>
+        <p:txBody>
+          <a:bodyPr/>
+          <a:lstStyle>
+            <a:lvl1pPr>
+              <a:defRPr sz="1000">
+                <a:solidFill>
+                  <a:schemeClr val="accent4"/>
+                </a:solidFill>
+              </a:defRPr>
+            </a:lvl1pPr>
+          </a:lstStyle>
+          <a:p>
+            <a:pPr algn="r"/>
+            <a:fld id="{F7021451-1387-4CA6-816F-3879F97B5CBC}" type="slidenum">
+              <a:rPr b="0" lang="en-US"/>
+              <a:t>7</a:t>
+            </a:fld>
+            <a:endParaRPr lang="en-US"/>
+          </a:p>
+        </p:txBody>
+      </p:sp>
+    </p:spTree>
+  </p:cSld>
+  <p:clrMapOvr>
+    <a:masterClrMapping/>
+  </p:clrMapOvr>
+</p:sld>
+</file>
+
+<file path=ppt/slides/slide8.xml><?xml version="1.0" encoding="utf-8"?>
+<p:sld xmlns:a="http://schemas.openxmlformats.org/drawingml/2006/main" xmlns:r="http://schemas.openxmlformats.org/officeDocument/2006/relationships" xmlns:p="http://schemas.openxmlformats.org/presentationml/2006/main">
+  <p:cSld name="Slide 8">
     <p:spTree>
       <p:nvGrpSpPr>
         <p:cNvPr id="1" name=""/>

</xml_diff>